<commit_message>
feat(slides): add block() helper in template colours
- Add block() to slide_kit with TEMPLATE['block'] colours and set accent to #3333B2
- Sample template slide 3 now shows a generic block element instead of a discussion layout
- Make the discussion step optional in the storyline and update docs and READMEs
</commit_message>
<xml_diff>
--- a/skills/paper-discussion-slides/assets/sample-template.pptx
+++ b/skills/paper-discussion-slides/assets/sample-template.pptx
@@ -715,7 +715,7 @@
           <a:lstStyle/>
           <a:p>
             <a:r>
-              <a:t>Blocks: accent title bar, light grey body with real bullets (bullets()), keywords and numbers only. The QR placeholder shows what qr() draws when no event link is known yet.</a:t>
+              <a:t>block() in the template colours; headings and columns are placeholders. The QR placeholder shows what qr() draws when no event link is known yet.</a:t>
             </a:r>
           </a:p>
         </p:txBody>
@@ -5506,7 +5506,7 @@
                 <a:latin typeface="Arial"/>
                 <a:ea typeface="Microsoft JhengHei"/>
               </a:rPr>
-              <a:t>Two blocks side by side (discussion)</a:t>
+              <a:t>Block element (layout is chosen per slide)</a:t>
             </a:r>
           </a:p>
         </p:txBody>
@@ -5736,7 +5736,7 @@
             </a:avLst>
           </a:prstGeom>
           <a:solidFill>
-            <a:srgbClr val="005AA0"/>
+            <a:srgbClr val="4747BA"/>
           </a:solidFill>
           <a:ln>
             <a:noFill/>
@@ -5774,7 +5774,7 @@
         <p:spPr>
           <a:xfrm>
             <a:off x="952500" y="2476500"/>
-            <a:ext cx="7620000" cy="666750"/>
+            <a:ext cx="7467600" cy="666750"/>
           </a:xfrm>
           <a:prstGeom prst="rect">
             <a:avLst/>
@@ -5796,7 +5796,7 @@
                 <a:latin typeface="Arial"/>
                 <a:ea typeface="Microsoft JhengHei"/>
               </a:rPr>
-              <a:t>Why it works</a:t>
+              <a:t>Block A</a:t>
             </a:r>
           </a:p>
         </p:txBody>
@@ -5818,7 +5818,7 @@
             </a:avLst>
           </a:prstGeom>
           <a:solidFill>
-            <a:srgbClr val="F0F0F0"/>
+            <a:srgbClr val="EBEBF7"/>
           </a:solidFill>
           <a:ln>
             <a:noFill/>
@@ -5856,7 +5856,7 @@
         <p:spPr>
           <a:xfrm>
             <a:off x="952500" y="3429000"/>
-            <a:ext cx="7524750" cy="3143250"/>
+            <a:ext cx="7467600" cy="3143250"/>
           </a:xfrm>
           <a:prstGeom prst="rect">
             <a:avLst/>
@@ -5884,7 +5884,7 @@
                 <a:latin typeface="Arial"/>
                 <a:ea typeface="Microsoft JhengHei"/>
               </a:rPr>
-              <a:t>point with a number</a:t>
+              <a:t>keyword or number</a:t>
             </a:r>
           </a:p>
           <a:p>
@@ -5903,7 +5903,7 @@
                 <a:latin typeface="Arial"/>
                 <a:ea typeface="Microsoft JhengHei"/>
               </a:rPr>
-              <a:t>second point</a:t>
+              <a:t>second keyword</a:t>
             </a:r>
           </a:p>
         </p:txBody>
@@ -5925,7 +5925,7 @@
             </a:avLst>
           </a:prstGeom>
           <a:solidFill>
-            <a:srgbClr val="005AA0"/>
+            <a:srgbClr val="4747BA"/>
           </a:solidFill>
           <a:ln>
             <a:noFill/>
@@ -5963,7 +5963,7 @@
         <p:spPr>
           <a:xfrm>
             <a:off x="9525000" y="2476500"/>
-            <a:ext cx="7620000" cy="666750"/>
+            <a:ext cx="7467600" cy="666750"/>
           </a:xfrm>
           <a:prstGeom prst="rect">
             <a:avLst/>
@@ -5985,7 +5985,7 @@
                 <a:latin typeface="Arial"/>
                 <a:ea typeface="Microsoft JhengHei"/>
               </a:rPr>
-              <a:t>Limits the authors admit</a:t>
+              <a:t>Block B</a:t>
             </a:r>
           </a:p>
         </p:txBody>
@@ -6007,7 +6007,7 @@
             </a:avLst>
           </a:prstGeom>
           <a:solidFill>
-            <a:srgbClr val="F0F0F0"/>
+            <a:srgbClr val="EBEBF7"/>
           </a:solidFill>
           <a:ln>
             <a:noFill/>
@@ -6045,7 +6045,7 @@
         <p:spPr>
           <a:xfrm>
             <a:off x="9525000" y="3429000"/>
-            <a:ext cx="7524750" cy="3143250"/>
+            <a:ext cx="7467600" cy="3143250"/>
           </a:xfrm>
           <a:prstGeom prst="rect">
             <a:avLst/>
@@ -6073,7 +6073,7 @@
                 <a:latin typeface="Arial"/>
                 <a:ea typeface="Microsoft JhengHei"/>
               </a:rPr>
-              <a:t>quote their wording</a:t>
+              <a:t>keyword or number</a:t>
             </a:r>
           </a:p>
           <a:p>
@@ -6092,7 +6092,7 @@
                 <a:latin typeface="Arial"/>
                 <a:ea typeface="Microsoft JhengHei"/>
               </a:rPr>
-              <a:t>"in some cases"</a:t>
+              <a:t>second keyword</a:t>
             </a:r>
           </a:p>
         </p:txBody>

</xml_diff>

<commit_message>
feat(slides): add dim_area() mask for dimming discussed content
Dim already-discussed content with a white mask (80% opacity, no outline, no shadow) over the whole region instead of fading each element. Earlier content stays readable for context, and because each build step is its own slide the effect survives PDF export.

- slide_kit: add dim_area(); dim() stays for fading a single element
- SKILL.md: make the mask the default way to dim; allow revealing a parallel list item by item when each item needs its own explanation and points back to a different earlier part of the talk
- pptx-techniques: document dim_area() and why builds use slides, not in-slide animation
- sample deck: step 2 uses dim_area(); preview regenerated
- bump version to 0.3.1

Co-Authored-By: Claude Opus 5.5 <noreply@anthropic.com>
</commit_message>
<xml_diff>
--- a/skills/paper-discussion-slides/assets/sample-template.pptx
+++ b/skills/paper-discussion-slides/assets/sample-template.pptx
@@ -645,7 +645,7 @@
           <a:lstStyle/>
           <a:p>
             <a:r>
-              <a:t>Build step 2 of 2: the previous callout and arrow are gone; the rest of the figure is dimmed only to show dimming; normally a frame circles part of an image and nothing is dimmed. Block arrow: this, therefore.</a:t>
+              <a:t>Build step 2 of 2: the previous callout and arrow are gone; the figure is dimmed with dim_area() only to show the mask (white, 80% opacity, no outline, no shadow); normally a frame circles part of an image and nothing is dimmed. Block arrow: this, therefore.</a:t>
             </a:r>
           </a:p>
         </p:txBody>
@@ -5044,9 +5044,7 @@
             </a:avLst>
           </a:prstGeom>
           <a:solidFill>
-            <a:srgbClr val="DCDCE4">
-              <a:alpha val="35000"/>
-            </a:srgbClr>
+            <a:srgbClr val="DCDCE4"/>
           </a:solidFill>
           <a:ln>
             <a:noFill/>
@@ -5101,9 +5099,7 @@
             <a:r>
               <a:rPr sz="2800" b="0" i="0">
                 <a:solidFill>
-                  <a:srgbClr val="5F5F6E">
-                    <a:alpha val="35000"/>
-                  </a:srgbClr>
+                  <a:srgbClr val="5F5F6E"/>
                 </a:solidFill>
                 <a:latin typeface="Arial"/>
                 <a:ea typeface="Microsoft JhengHei"/>
@@ -5151,7 +5147,53 @@
       </p:sp>
       <p:sp>
         <p:nvSpPr>
-          <p:cNvPr id="13" name="Rounded Rectangle 12"/>
+          <p:cNvPr id="13" name="Rectangle 12"/>
+          <p:cNvSpPr/>
+          <p:nvPr/>
+        </p:nvSpPr>
+        <p:spPr>
+          <a:xfrm>
+            <a:off x="685800" y="2286000"/>
+            <a:ext cx="9525000" cy="5334000"/>
+          </a:xfrm>
+          <a:prstGeom prst="rect">
+            <a:avLst/>
+          </a:prstGeom>
+          <a:solidFill>
+            <a:srgbClr val="FFFFFF">
+              <a:alpha val="80000"/>
+            </a:srgbClr>
+          </a:solidFill>
+          <a:ln>
+            <a:noFill/>
+          </a:ln>
+          <a:effectLst/>
+        </p:spPr>
+        <p:style>
+          <a:lnRef idx="1">
+            <a:schemeClr val="accent1"/>
+          </a:lnRef>
+          <a:fillRef idx="3">
+            <a:schemeClr val="accent1"/>
+          </a:fillRef>
+          <a:effectRef idx="2">
+            <a:schemeClr val="accent1"/>
+          </a:effectRef>
+          <a:fontRef idx="minor">
+            <a:schemeClr val="lt1"/>
+          </a:fontRef>
+        </p:style>
+        <p:txBody>
+          <a:bodyPr rtlCol="0" anchor="ctr"/>
+          <a:lstStyle/>
+          <a:p>
+            <a:pPr algn="ctr"/>
+          </a:p>
+        </p:txBody>
+      </p:sp>
+      <p:sp>
+        <p:nvSpPr>
+          <p:cNvPr id="14" name="Rounded Rectangle 13"/>
           <p:cNvSpPr/>
           <p:nvPr/>
         </p:nvSpPr>
@@ -5197,7 +5239,7 @@
       </p:sp>
       <p:sp>
         <p:nvSpPr>
-          <p:cNvPr id="14" name="Rounded Rectangle 13"/>
+          <p:cNvPr id="15" name="Rounded Rectangle 14"/>
           <p:cNvSpPr/>
           <p:nvPr/>
         </p:nvSpPr>
@@ -5243,7 +5285,7 @@
       </p:sp>
       <p:sp>
         <p:nvSpPr>
-          <p:cNvPr id="15" name="Rounded Rectangle 14"/>
+          <p:cNvPr id="16" name="Rounded Rectangle 15"/>
           <p:cNvSpPr/>
           <p:nvPr/>
         </p:nvSpPr>
@@ -5291,7 +5333,7 @@
       </p:sp>
       <p:sp>
         <p:nvSpPr>
-          <p:cNvPr id="16" name="TextBox 15"/>
+          <p:cNvPr id="17" name="TextBox 16"/>
           <p:cNvSpPr txBox="1"/>
           <p:nvPr/>
         </p:nvSpPr>
@@ -5327,7 +5369,7 @@
       </p:sp>
       <p:sp>
         <p:nvSpPr>
-          <p:cNvPr id="17" name="Right Arrow 16"/>
+          <p:cNvPr id="18" name="Right Arrow 17"/>
           <p:cNvSpPr/>
           <p:nvPr/>
         </p:nvSpPr>

</xml_diff>